<commit_message>
Update PowerPoint for song #38 in FUBC - Українські
</commit_message>
<xml_diff>
--- a/fubc-ua/38-О Господи Боже, благаю Тебе (Пісні Спасенних №29).pptx
+++ b/fubc-ua/38-О Господи Боже, благаю Тебе (Пісні Спасенних №29).pptx
@@ -1535,23 +1535,6 @@
             </a:r>
             <a:endParaRPr lang="en-US" sz="5000" dirty="0"/>
           </a:p>
-          <a:p>
-            <a:pPr algn="ctr" indent="0" marL="0">
-              <a:buNone/>
-            </a:pPr>
-            <a:r>
-              <a:rPr lang="en-US" sz="5000" b="1" dirty="0">
-                <a:solidFill>
-                  <a:srgbClr val="FFFFFF"/>
-                </a:solidFill>
-                <a:latin typeface="Arial" pitchFamily="34" charset="0"/>
-                <a:ea typeface="Arial" pitchFamily="34" charset="-122"/>
-                <a:cs typeface="Arial" pitchFamily="34" charset="-120"/>
-              </a:rPr>
-              <a:t>(Пісні Спасенних №29)</a:t>
-            </a:r>
-            <a:endParaRPr lang="en-US" sz="5000" dirty="0"/>
-          </a:p>
         </p:txBody>
       </p:sp>
     </p:spTree>
@@ -1611,7 +1594,7 @@
               <a:buNone/>
             </a:pPr>
             <a:r>
-              <a:rPr lang="en-US" sz="5000" b="1" dirty="0">
+              <a:rPr lang="en-US" sz="4400" b="1" dirty="0">
                 <a:solidFill>
                   <a:srgbClr val="FFFFFF"/>
                 </a:solidFill>
@@ -1621,14 +1604,14 @@
               </a:rPr>
               <a:t>О Господи Боже, благаю Тебе:</a:t>
             </a:r>
-            <a:endParaRPr lang="en-US" sz="5000" dirty="0"/>
+            <a:endParaRPr lang="en-US" sz="4400" dirty="0"/>
           </a:p>
           <a:p>
             <a:pPr algn="ctr" indent="0" marL="0">
               <a:buNone/>
             </a:pPr>
             <a:r>
-              <a:rPr lang="en-US" sz="5000" b="1" dirty="0">
+              <a:rPr lang="en-US" sz="4400" b="1" dirty="0">
                 <a:solidFill>
                   <a:srgbClr val="FFFFFF"/>
                 </a:solidFill>
@@ -1638,14 +1621,14 @@
               </a:rPr>
               <a:t>візьми в Свою власність життя все моє,</a:t>
             </a:r>
-            <a:endParaRPr lang="en-US" sz="5000" dirty="0"/>
+            <a:endParaRPr lang="en-US" sz="4400" dirty="0"/>
           </a:p>
           <a:p>
             <a:pPr algn="ctr" indent="0" marL="0">
               <a:buNone/>
             </a:pPr>
             <a:r>
-              <a:rPr lang="en-US" sz="5000" b="1" dirty="0">
+              <a:rPr lang="en-US" sz="4400" b="1" dirty="0">
                 <a:solidFill>
                   <a:srgbClr val="FFFFFF"/>
                 </a:solidFill>
@@ -1655,14 +1638,14 @@
               </a:rPr>
               <a:t>зміцни в серці віру і дух обнови,</a:t>
             </a:r>
-            <a:endParaRPr lang="en-US" sz="5000" dirty="0"/>
+            <a:endParaRPr lang="en-US" sz="4400" dirty="0"/>
           </a:p>
           <a:p>
             <a:pPr algn="ctr" indent="0" marL="0">
               <a:buNone/>
             </a:pPr>
             <a:r>
-              <a:rPr lang="en-US" sz="5000" b="1" dirty="0">
+              <a:rPr lang="en-US" sz="4400" b="1" dirty="0">
                 <a:solidFill>
                   <a:srgbClr val="FFFFFF"/>
                 </a:solidFill>
@@ -1672,7 +1655,7 @@
               </a:rPr>
               <a:t>Своє милосердя до мене яви.</a:t>
             </a:r>
-            <a:endParaRPr lang="en-US" sz="5000" dirty="0"/>
+            <a:endParaRPr lang="en-US" sz="4400" dirty="0"/>
           </a:p>
         </p:txBody>
       </p:sp>
@@ -1741,24 +1724,7 @@
                 <a:ea typeface="Arial" pitchFamily="34" charset="-122"/>
                 <a:cs typeface="Arial" pitchFamily="34" charset="-120"/>
               </a:rPr>
-              <a:t>Кровʼю обмий (обмий),</a:t>
-            </a:r>
-            <a:endParaRPr lang="en-US" sz="5000" dirty="0"/>
-          </a:p>
-          <a:p>
-            <a:pPr algn="ctr" indent="0" marL="0">
-              <a:buNone/>
-            </a:pPr>
-            <a:r>
-              <a:rPr lang="en-US" sz="5000" b="1" i="1" dirty="0">
-                <a:solidFill>
-                  <a:srgbClr val="FFFFFF"/>
-                </a:solidFill>
-                <a:latin typeface="Arial" pitchFamily="34" charset="0"/>
-                <a:ea typeface="Arial" pitchFamily="34" charset="-122"/>
-                <a:cs typeface="Arial" pitchFamily="34" charset="-120"/>
-              </a:rPr>
-              <a:t>кровʼю обмий (обмий),</a:t>
+              <a:t>Кровʼю обмий, кровʼю обмий,</a:t>
             </a:r>
             <a:endParaRPr lang="en-US" sz="5000" dirty="0"/>
           </a:p>
@@ -1855,7 +1821,7 @@
               <a:buNone/>
             </a:pPr>
             <a:r>
-              <a:rPr lang="en-US" sz="5000" b="1" dirty="0">
+              <a:rPr lang="en-US" sz="4500" b="1" dirty="0">
                 <a:solidFill>
                   <a:srgbClr val="FFFFFF"/>
                 </a:solidFill>
@@ -1865,14 +1831,14 @@
               </a:rPr>
               <a:t>О Господи Боже, дай сили мені</a:t>
             </a:r>
-            <a:endParaRPr lang="en-US" sz="5000" dirty="0"/>
+            <a:endParaRPr lang="en-US" sz="4500" dirty="0"/>
           </a:p>
           <a:p>
             <a:pPr algn="ctr" indent="0" marL="0">
               <a:buNone/>
             </a:pPr>
             <a:r>
-              <a:rPr lang="en-US" sz="5000" b="1" dirty="0">
+              <a:rPr lang="en-US" sz="4500" b="1" dirty="0">
                 <a:solidFill>
                   <a:srgbClr val="FFFFFF"/>
                 </a:solidFill>
@@ -1882,14 +1848,14 @@
               </a:rPr>
               <a:t>цілком і назавжди віддатись Тобі;</a:t>
             </a:r>
-            <a:endParaRPr lang="en-US" sz="5000" dirty="0"/>
+            <a:endParaRPr lang="en-US" sz="4500" dirty="0"/>
           </a:p>
           <a:p>
             <a:pPr algn="ctr" indent="0" marL="0">
               <a:buNone/>
             </a:pPr>
             <a:r>
-              <a:rPr lang="en-US" sz="5000" b="1" dirty="0">
+              <a:rPr lang="en-US" sz="4500" b="1" dirty="0">
                 <a:solidFill>
                   <a:srgbClr val="FFFFFF"/>
                 </a:solidFill>
@@ -1899,14 +1865,14 @@
               </a:rPr>
               <a:t>пролий знову в серце святу благодать,</a:t>
             </a:r>
-            <a:endParaRPr lang="en-US" sz="5000" dirty="0"/>
+            <a:endParaRPr lang="en-US" sz="4500" dirty="0"/>
           </a:p>
           <a:p>
             <a:pPr algn="ctr" indent="0" marL="0">
               <a:buNone/>
             </a:pPr>
             <a:r>
-              <a:rPr lang="en-US" sz="5000" b="1" dirty="0">
+              <a:rPr lang="en-US" sz="4500" b="1" dirty="0">
                 <a:solidFill>
                   <a:srgbClr val="FFFFFF"/>
                 </a:solidFill>
@@ -1916,7 +1882,7 @@
               </a:rPr>
               <a:t>щоб завжди я славив Твоє лиш Імʼя.</a:t>
             </a:r>
-            <a:endParaRPr lang="en-US" sz="5000" dirty="0"/>
+            <a:endParaRPr lang="en-US" sz="4500" dirty="0"/>
           </a:p>
         </p:txBody>
       </p:sp>
@@ -1985,24 +1951,7 @@
                 <a:ea typeface="Arial" pitchFamily="34" charset="-122"/>
                 <a:cs typeface="Arial" pitchFamily="34" charset="-120"/>
               </a:rPr>
-              <a:t>Кровʼю обмий (обмий),</a:t>
-            </a:r>
-            <a:endParaRPr lang="en-US" sz="5000" dirty="0"/>
-          </a:p>
-          <a:p>
-            <a:pPr algn="ctr" indent="0" marL="0">
-              <a:buNone/>
-            </a:pPr>
-            <a:r>
-              <a:rPr lang="en-US" sz="5000" b="1" i="1" dirty="0">
-                <a:solidFill>
-                  <a:srgbClr val="FFFFFF"/>
-                </a:solidFill>
-                <a:latin typeface="Arial" pitchFamily="34" charset="0"/>
-                <a:ea typeface="Arial" pitchFamily="34" charset="-122"/>
-                <a:cs typeface="Arial" pitchFamily="34" charset="-120"/>
-              </a:rPr>
-              <a:t>кровʼю обмий (обмий),</a:t>
+              <a:t>Кровʼю обмий, кровʼю обмий,</a:t>
             </a:r>
             <a:endParaRPr lang="en-US" sz="5000" dirty="0"/>
           </a:p>
@@ -2099,7 +2048,7 @@
               <a:buNone/>
             </a:pPr>
             <a:r>
-              <a:rPr lang="en-US" sz="5000" b="1" dirty="0">
+              <a:rPr lang="en-US" sz="4900" b="1" dirty="0">
                 <a:solidFill>
                   <a:srgbClr val="FFFFFF"/>
                 </a:solidFill>
@@ -2109,14 +2058,14 @@
               </a:rPr>
               <a:t>Обмий мою душу в пречистій крові,</a:t>
             </a:r>
-            <a:endParaRPr lang="en-US" sz="5000" dirty="0"/>
+            <a:endParaRPr lang="en-US" sz="4900" dirty="0"/>
           </a:p>
           <a:p>
             <a:pPr algn="ctr" indent="0" marL="0">
               <a:buNone/>
             </a:pPr>
             <a:r>
-              <a:rPr lang="en-US" sz="5000" b="1" dirty="0">
+              <a:rPr lang="en-US" sz="4900" b="1" dirty="0">
                 <a:solidFill>
                   <a:srgbClr val="FFFFFF"/>
                 </a:solidFill>
@@ -2126,14 +2075,14 @@
               </a:rPr>
               <a:t>і стану білішим від снігу тоді.</a:t>
             </a:r>
-            <a:endParaRPr lang="en-US" sz="5000" dirty="0"/>
+            <a:endParaRPr lang="en-US" sz="4900" dirty="0"/>
           </a:p>
           <a:p>
             <a:pPr algn="ctr" indent="0" marL="0">
               <a:buNone/>
             </a:pPr>
             <a:r>
-              <a:rPr lang="en-US" sz="5000" b="1" dirty="0">
+              <a:rPr lang="en-US" sz="4900" b="1" dirty="0">
                 <a:solidFill>
                   <a:srgbClr val="FFFFFF"/>
                 </a:solidFill>
@@ -2143,14 +2092,14 @@
               </a:rPr>
               <a:t>Благаю: дай твердість у вірі мені,</a:t>
             </a:r>
-            <a:endParaRPr lang="en-US" sz="5000" dirty="0"/>
+            <a:endParaRPr lang="en-US" sz="4900" dirty="0"/>
           </a:p>
           <a:p>
             <a:pPr algn="ctr" indent="0" marL="0">
               <a:buNone/>
             </a:pPr>
             <a:r>
-              <a:rPr lang="en-US" sz="5000" b="1" dirty="0">
+              <a:rPr lang="en-US" sz="4900" b="1" dirty="0">
                 <a:solidFill>
                   <a:srgbClr val="FFFFFF"/>
                 </a:solidFill>
@@ -2160,7 +2109,7 @@
               </a:rPr>
               <a:t>зроби мене, Боже, приємним Тобі.</a:t>
             </a:r>
-            <a:endParaRPr lang="en-US" sz="5000" dirty="0"/>
+            <a:endParaRPr lang="en-US" sz="4900" dirty="0"/>
           </a:p>
         </p:txBody>
       </p:sp>
@@ -2229,24 +2178,7 @@
                 <a:ea typeface="Arial" pitchFamily="34" charset="-122"/>
                 <a:cs typeface="Arial" pitchFamily="34" charset="-120"/>
               </a:rPr>
-              <a:t>Кровʼю обмий (обмий),</a:t>
-            </a:r>
-            <a:endParaRPr lang="en-US" sz="5000" dirty="0"/>
-          </a:p>
-          <a:p>
-            <a:pPr algn="ctr" indent="0" marL="0">
-              <a:buNone/>
-            </a:pPr>
-            <a:r>
-              <a:rPr lang="en-US" sz="5000" b="1" i="1" dirty="0">
-                <a:solidFill>
-                  <a:srgbClr val="FFFFFF"/>
-                </a:solidFill>
-                <a:latin typeface="Arial" pitchFamily="34" charset="0"/>
-                <a:ea typeface="Arial" pitchFamily="34" charset="-122"/>
-                <a:cs typeface="Arial" pitchFamily="34" charset="-120"/>
-              </a:rPr>
-              <a:t>кровʼю обмий (обмий),</a:t>
+              <a:t>Кровʼю обмий, кровʼю обмий,</a:t>
             </a:r>
             <a:endParaRPr lang="en-US" sz="5000" dirty="0"/>
           </a:p>

</xml_diff>